<commit_message>
Reflect the field-facing features in the submission deck
The deck was written before satellite view, voice search, five languages and
shipment tracking existed, so it undersold what the app now does.

Slide 2 (Innovation and uniqueness): added a third bullet naming these
directly - voice search, satellite view, shipment tracking, five languages -
since this is exactly the pointer a judge reads to answer 'why this one'.

Slide 3 (Technologies to be used): split Frontend into Frontend + a new
Interface column (Web Speech API, 5 languages, shipment tracking) rather than
burying them in one crowded cell. Verified by dumping every text box's exact
position: no two boxes overlap, and both edited slides still clear the
footer with margin to spare.

Co-Authored-By: Claude Sonnet 5 <noreply@anthropic.com>
Claude-Session: https://claude.ai/code/session_019Z9VN4HuEWYiB2x7TMSUd8
</commit_message>
<xml_diff>
--- a/docs/presentation/SIH26002_NER_Logistics_Submission6.pptx
+++ b/docs/presentation/SIH26002_NER_Logistics_Submission6.pptx
@@ -6774,7 +6774,7 @@
         </p:nvSpPr>
         <p:spPr>
           <a:xfrm>
-            <a:off x="502920" y="4279392"/>
+            <a:off x="502920" y="4206240"/>
             <a:ext cx="365760" cy="329184"/>
           </a:xfrm>
           <a:prstGeom prst="rect">
@@ -6816,7 +6816,7 @@
         </p:nvSpPr>
         <p:spPr>
           <a:xfrm>
-            <a:off x="502920" y="4279392"/>
+            <a:off x="502920" y="4206240"/>
             <a:ext cx="365760" cy="329184"/>
           </a:xfrm>
           <a:prstGeom prst="rect">
@@ -6858,7 +6858,7 @@
         </p:nvSpPr>
         <p:spPr>
           <a:xfrm>
-            <a:off x="978408" y="4279392"/>
+            <a:off x="978408" y="4206240"/>
             <a:ext cx="6428231" cy="329184"/>
           </a:xfrm>
           <a:prstGeom prst="rect">
@@ -6900,8 +6900,8 @@
         </p:nvSpPr>
         <p:spPr>
           <a:xfrm>
-            <a:off x="978408" y="4663440"/>
-            <a:ext cx="6428231" cy="1051560"/>
+            <a:off x="978408" y="4572000"/>
+            <a:ext cx="6428231" cy="1600200"/>
           </a:xfrm>
           <a:prstGeom prst="rect">
             <a:avLst/>
@@ -6916,14 +6916,14 @@
           <a:p>
             <a:pPr algn="l">
               <a:lnSpc>
-                <a:spcPct val="118000"/>
+                <a:spcPct val="114000"/>
               </a:lnSpc>
               <a:spcAft>
-                <a:spcPts val="900"/>
+                <a:spcPts val="700"/>
               </a:spcAft>
             </a:pPr>
             <a:r>
-              <a:rPr sz="1250" b="0" i="0">
+              <a:rPr sz="1200" b="0" i="0">
                 <a:solidFill>
                   <a:srgbClr val="1A1A1A"/>
                 </a:solidFill>
@@ -6935,20 +6935,39 @@
           <a:p>
             <a:pPr algn="l">
               <a:lnSpc>
-                <a:spcPct val="118000"/>
+                <a:spcPct val="114000"/>
               </a:lnSpc>
               <a:spcAft>
-                <a:spcPts val="900"/>
+                <a:spcPts val="700"/>
               </a:spcAft>
             </a:pPr>
             <a:r>
-              <a:rPr sz="1250" b="0" i="0">
+              <a:rPr sz="1200" b="0" i="0">
                 <a:solidFill>
                   <a:srgbClr val="1A1A1A"/>
                 </a:solidFill>
                 <a:latin typeface="Calibri"/>
               </a:rPr>
               <a:t>-  Landslides and floods are scored separately, since they happen on different terrain in different seasons - and the whole thing runs on free data, so there is no cost to keep it running.</a:t>
+            </a:r>
+          </a:p>
+          <a:p>
+            <a:pPr algn="l">
+              <a:lnSpc>
+                <a:spcPct val="114000"/>
+              </a:lnSpc>
+              <a:spcAft>
+                <a:spcPts val="700"/>
+              </a:spcAft>
+            </a:pPr>
+            <a:r>
+              <a:rPr sz="1200" b="0" i="0">
+                <a:solidFill>
+                  <a:srgbClr val="1A1A1A"/>
+                </a:solidFill>
+                <a:latin typeface="Calibri"/>
+              </a:rPr>
+              <a:t>-  Built for the field, not just for a lab demo: search a place by voice, switch to satellite view, watch the shipment move leg by leg on the map, and use the whole app in five languages.</a:t>
             </a:r>
           </a:p>
         </p:txBody>
@@ -7672,7 +7691,7 @@
         <p:spPr>
           <a:xfrm>
             <a:off x="502920" y="2084832"/>
-            <a:ext cx="2679192" cy="676656"/>
+            <a:ext cx="2040940" cy="749808"/>
           </a:xfrm>
           <a:prstGeom prst="rect">
             <a:avLst/>
@@ -7713,8 +7732,8 @@
         </p:nvSpPr>
         <p:spPr>
           <a:xfrm>
-            <a:off x="630936" y="2157984"/>
-            <a:ext cx="2423160" cy="548640"/>
+            <a:off x="612648" y="2157984"/>
+            <a:ext cx="1821484" cy="621792"/>
           </a:xfrm>
           <a:prstGeom prst="rect">
             <a:avLst/>
@@ -7736,7 +7755,7 @@
               </a:spcAft>
             </a:pPr>
             <a:r>
-              <a:rPr sz="1000" b="1" i="0">
+              <a:rPr sz="950" b="1" i="0">
                 <a:solidFill>
                   <a:srgbClr val="1F4E79"/>
                 </a:solidFill>
@@ -7755,13 +7774,13 @@
               </a:spcAft>
             </a:pPr>
             <a:r>
-              <a:rPr sz="1050" b="0" i="0">
+              <a:rPr sz="950" b="0" i="0">
                 <a:solidFill>
                   <a:srgbClr val="1A1A1A"/>
                 </a:solidFill>
                 <a:latin typeface="Calibri"/>
               </a:rPr>
-              <a:t>Python  ·  FastAPI  ·  NetworkX  ·  scikit-learn (optional)</a:t>
+              <a:t>Python · FastAPI · NetworkX · scikit-learn (optional)</a:t>
             </a:r>
           </a:p>
         </p:txBody>
@@ -7774,8 +7793,8 @@
         </p:nvSpPr>
         <p:spPr>
           <a:xfrm>
-            <a:off x="3300984" y="2084832"/>
-            <a:ext cx="2679192" cy="676656"/>
+            <a:off x="2662732" y="2084832"/>
+            <a:ext cx="2040940" cy="749808"/>
           </a:xfrm>
           <a:prstGeom prst="rect">
             <a:avLst/>
@@ -7816,8 +7835,8 @@
         </p:nvSpPr>
         <p:spPr>
           <a:xfrm>
-            <a:off x="3429000" y="2157984"/>
-            <a:ext cx="2423160" cy="548640"/>
+            <a:off x="2772460" y="2157984"/>
+            <a:ext cx="1821484" cy="621792"/>
           </a:xfrm>
           <a:prstGeom prst="rect">
             <a:avLst/>
@@ -7839,7 +7858,7 @@
               </a:spcAft>
             </a:pPr>
             <a:r>
-              <a:rPr sz="1000" b="1" i="0">
+              <a:rPr sz="950" b="1" i="0">
                 <a:solidFill>
                   <a:srgbClr val="1F4E79"/>
                 </a:solidFill>
@@ -7858,13 +7877,13 @@
               </a:spcAft>
             </a:pPr>
             <a:r>
-              <a:rPr sz="1050" b="0" i="0">
+              <a:rPr sz="950" b="0" i="0">
                 <a:solidFill>
                   <a:srgbClr val="1A1A1A"/>
                 </a:solidFill>
                 <a:latin typeface="Calibri"/>
               </a:rPr>
-              <a:t>OpenStreetMap  ·  NASA POWER  ·  Copernicus DEM</a:t>
+              <a:t>OpenStreetMap · NASA POWER · Copernicus DEM</a:t>
             </a:r>
           </a:p>
         </p:txBody>
@@ -7877,8 +7896,8 @@
         </p:nvSpPr>
         <p:spPr>
           <a:xfrm>
-            <a:off x="6099048" y="2084832"/>
-            <a:ext cx="2679192" cy="676656"/>
+            <a:off x="4822545" y="2084832"/>
+            <a:ext cx="2040940" cy="749808"/>
           </a:xfrm>
           <a:prstGeom prst="rect">
             <a:avLst/>
@@ -7919,8 +7938,8 @@
         </p:nvSpPr>
         <p:spPr>
           <a:xfrm>
-            <a:off x="6227064" y="2157984"/>
-            <a:ext cx="2423160" cy="548640"/>
+            <a:off x="4932273" y="2157984"/>
+            <a:ext cx="1821484" cy="621792"/>
           </a:xfrm>
           <a:prstGeom prst="rect">
             <a:avLst/>
@@ -7942,7 +7961,7 @@
               </a:spcAft>
             </a:pPr>
             <a:r>
-              <a:rPr sz="1000" b="1" i="0">
+              <a:rPr sz="950" b="1" i="0">
                 <a:solidFill>
                   <a:srgbClr val="1F4E79"/>
                 </a:solidFill>
@@ -7961,13 +7980,13 @@
               </a:spcAft>
             </a:pPr>
             <a:r>
-              <a:rPr sz="1050" b="0" i="0">
+              <a:rPr sz="950" b="0" i="0">
                 <a:solidFill>
                   <a:srgbClr val="1A1A1A"/>
                 </a:solidFill>
                 <a:latin typeface="Calibri"/>
               </a:rPr>
-              <a:t>MapLibre GL - vendored, zero build step</a:t>
+              <a:t>MapLibre GL - vector + satellite, no build step</a:t>
             </a:r>
           </a:p>
         </p:txBody>
@@ -7980,8 +7999,8 @@
         </p:nvSpPr>
         <p:spPr>
           <a:xfrm>
-            <a:off x="8897112" y="2084832"/>
-            <a:ext cx="2679192" cy="676656"/>
+            <a:off x="6982358" y="2084832"/>
+            <a:ext cx="2040940" cy="749808"/>
           </a:xfrm>
           <a:prstGeom prst="rect">
             <a:avLst/>
@@ -8022,8 +8041,8 @@
         </p:nvSpPr>
         <p:spPr>
           <a:xfrm>
-            <a:off x="9025128" y="2157984"/>
-            <a:ext cx="2423160" cy="548640"/>
+            <a:off x="7092086" y="2157984"/>
+            <a:ext cx="1821484" cy="621792"/>
           </a:xfrm>
           <a:prstGeom prst="rect">
             <a:avLst/>
@@ -8045,13 +8064,13 @@
               </a:spcAft>
             </a:pPr>
             <a:r>
-              <a:rPr sz="1000" b="1" i="0">
+              <a:rPr sz="950" b="1" i="0">
                 <a:solidFill>
                   <a:srgbClr val="1F4E79"/>
                 </a:solidFill>
                 <a:latin typeface="Calibri"/>
               </a:rPr>
-              <a:t>TESTING</a:t>
+              <a:t>INTERFACE</a:t>
             </a:r>
           </a:p>
           <a:p>
@@ -8064,13 +8083,13 @@
               </a:spcAft>
             </a:pPr>
             <a:r>
-              <a:rPr sz="1050" b="0" i="0">
+              <a:rPr sz="950" b="0" i="0">
                 <a:solidFill>
                   <a:srgbClr val="1A1A1A"/>
                 </a:solidFill>
                 <a:latin typeface="Calibri"/>
               </a:rPr>
-              <a:t>pytest - 261 tests  ·  Playwright - 30 UI checks</a:t>
+              <a:t>Web Speech API (voice) · 5 languages · shipment tracking</a:t>
             </a:r>
           </a:p>
         </p:txBody>
@@ -8083,14 +8102,14 @@
         </p:nvSpPr>
         <p:spPr>
           <a:xfrm>
-            <a:off x="502920" y="2980944"/>
-            <a:ext cx="365760" cy="329184"/>
+            <a:off x="9142171" y="2084832"/>
+            <a:ext cx="2040940" cy="749808"/>
           </a:xfrm>
           <a:prstGeom prst="rect">
             <a:avLst/>
           </a:prstGeom>
           <a:solidFill>
-            <a:srgbClr val="1A1A1A"/>
+            <a:srgbClr val="F0F0F0"/>
           </a:solidFill>
           <a:ln>
             <a:noFill/>
@@ -8125,8 +8144,8 @@
         </p:nvSpPr>
         <p:spPr>
           <a:xfrm>
-            <a:off x="502920" y="2980944"/>
-            <a:ext cx="365760" cy="329184"/>
+            <a:off x="9251899" y="2157984"/>
+            <a:ext cx="1821484" cy="621792"/>
           </a:xfrm>
           <a:prstGeom prst="rect">
             <a:avLst/>
@@ -8134,113 +8153,69 @@
           <a:noFill/>
         </p:spPr>
         <p:txBody>
-          <a:bodyPr wrap="square" lIns="0" rIns="0" tIns="0" bIns="0" anchor="ctr">
+          <a:bodyPr wrap="square" lIns="0" rIns="0" tIns="0" bIns="0" anchor="t">
             <a:spAutoFit/>
           </a:bodyPr>
           <a:lstStyle/>
           <a:p>
-            <a:pPr algn="ctr">
+            <a:pPr algn="l">
               <a:lnSpc>
-                <a:spcPct val="100000"/>
+                <a:spcPct val="115000"/>
+              </a:lnSpc>
+              <a:spcAft>
+                <a:spcPts val="200"/>
+              </a:spcAft>
+            </a:pPr>
+            <a:r>
+              <a:rPr sz="950" b="1" i="0">
+                <a:solidFill>
+                  <a:srgbClr val="1F4E79"/>
+                </a:solidFill>
+                <a:latin typeface="Calibri"/>
+              </a:rPr>
+              <a:t>TESTING</a:t>
+            </a:r>
+          </a:p>
+          <a:p>
+            <a:pPr algn="l">
+              <a:lnSpc>
+                <a:spcPct val="110000"/>
               </a:lnSpc>
               <a:spcAft>
                 <a:spcPts val="0"/>
               </a:spcAft>
             </a:pPr>
             <a:r>
-              <a:rPr sz="1100" b="1" i="0">
-                <a:solidFill>
-                  <a:srgbClr val="FFFFFF"/>
+              <a:rPr sz="950" b="0" i="0">
+                <a:solidFill>
+                  <a:srgbClr val="1A1A1A"/>
                 </a:solidFill>
                 <a:latin typeface="Calibri"/>
               </a:rPr>
-              <a:t>02</a:t>
-            </a:r>
-          </a:p>
-        </p:txBody>
-      </p:sp>
-      <p:sp>
-        <p:nvSpPr>
-          <p:cNvPr id="17424" name="TextBox 17423"/>
-          <p:cNvSpPr txBox="1"/>
-          <p:nvPr/>
-        </p:nvSpPr>
-        <p:spPr>
-          <a:xfrm>
-            <a:off x="978408" y="2953512"/>
-            <a:ext cx="10707624" cy="502920"/>
-          </a:xfrm>
-          <a:prstGeom prst="rect">
-            <a:avLst/>
-          </a:prstGeom>
-          <a:noFill/>
-        </p:spPr>
-        <p:txBody>
-          <a:bodyPr wrap="square" lIns="0" rIns="0" tIns="0" bIns="0" anchor="t">
-            <a:spAutoFit/>
-          </a:bodyPr>
-          <a:lstStyle/>
-          <a:p>
-            <a:pPr algn="l">
-              <a:lnSpc>
-                <a:spcPct val="100000"/>
-              </a:lnSpc>
-              <a:spcAft>
-                <a:spcPts val="100"/>
-              </a:spcAft>
-            </a:pPr>
-            <a:r>
-              <a:rPr sz="1300" b="1" i="0">
-                <a:solidFill>
-                  <a:srgbClr val="1A1A1A"/>
-                </a:solidFill>
-                <a:latin typeface="Calibri"/>
-              </a:rPr>
-              <a:t>Methodology and process for implementation</a:t>
-            </a:r>
-          </a:p>
-          <a:p>
-            <a:pPr algn="l">
-              <a:lnSpc>
-                <a:spcPct val="100000"/>
-              </a:lnSpc>
-              <a:spcAft>
-                <a:spcPts val="0"/>
-              </a:spcAft>
-            </a:pPr>
-            <a:r>
-              <a:rPr sz="1000" b="0" i="1">
-                <a:solidFill>
-                  <a:srgbClr val="505050"/>
-                </a:solidFill>
-                <a:latin typeface="Calibri"/>
-              </a:rPr>
-              <a:t>(Flow Charts / Images / working prototype)</a:t>
-            </a:r>
-          </a:p>
-        </p:txBody>
-      </p:sp>
-      <p:sp>
-        <p:nvSpPr>
-          <p:cNvPr id="17425" name="Rectangle 17424"/>
+              <a:t>pytest - 261 tests · Playwright - 30+ UI checks</a:t>
+            </a:r>
+          </a:p>
+        </p:txBody>
+      </p:sp>
+      <p:sp>
+        <p:nvSpPr>
+          <p:cNvPr id="17424" name="Rectangle 17423"/>
           <p:cNvSpPr/>
           <p:nvPr/>
         </p:nvSpPr>
         <p:spPr>
           <a:xfrm>
-            <a:off x="502920" y="3621024"/>
-            <a:ext cx="1993392" cy="1417320"/>
+            <a:off x="502920" y="3017520"/>
+            <a:ext cx="365760" cy="329184"/>
           </a:xfrm>
           <a:prstGeom prst="rect">
             <a:avLst/>
           </a:prstGeom>
           <a:solidFill>
-            <a:srgbClr val="FFFFFF"/>
+            <a:srgbClr val="1A1A1A"/>
           </a:solidFill>
-          <a:ln w="9525">
-            <a:solidFill>
-              <a:srgbClr val="BFBFBF"/>
-            </a:solidFill>
+          <a:ln>
+            <a:noFill/>
           </a:ln>
           <a:effectLst/>
         </p:spPr>
@@ -8266,23 +8241,128 @@
       </p:sp>
       <p:sp>
         <p:nvSpPr>
-          <p:cNvPr id="17426" name="Rectangle 17425"/>
+          <p:cNvPr id="17425" name="TextBox 17424"/>
+          <p:cNvSpPr txBox="1"/>
+          <p:nvPr/>
+        </p:nvSpPr>
+        <p:spPr>
+          <a:xfrm>
+            <a:off x="502920" y="3017520"/>
+            <a:ext cx="365760" cy="329184"/>
+          </a:xfrm>
+          <a:prstGeom prst="rect">
+            <a:avLst/>
+          </a:prstGeom>
+          <a:noFill/>
+        </p:spPr>
+        <p:txBody>
+          <a:bodyPr wrap="square" lIns="0" rIns="0" tIns="0" bIns="0" anchor="ctr">
+            <a:spAutoFit/>
+          </a:bodyPr>
+          <a:lstStyle/>
+          <a:p>
+            <a:pPr algn="ctr">
+              <a:lnSpc>
+                <a:spcPct val="100000"/>
+              </a:lnSpc>
+              <a:spcAft>
+                <a:spcPts val="0"/>
+              </a:spcAft>
+            </a:pPr>
+            <a:r>
+              <a:rPr sz="1100" b="1" i="0">
+                <a:solidFill>
+                  <a:srgbClr val="FFFFFF"/>
+                </a:solidFill>
+                <a:latin typeface="Calibri"/>
+              </a:rPr>
+              <a:t>02</a:t>
+            </a:r>
+          </a:p>
+        </p:txBody>
+      </p:sp>
+      <p:sp>
+        <p:nvSpPr>
+          <p:cNvPr id="17426" name="TextBox 17425"/>
+          <p:cNvSpPr txBox="1"/>
+          <p:nvPr/>
+        </p:nvSpPr>
+        <p:spPr>
+          <a:xfrm>
+            <a:off x="978408" y="2990088"/>
+            <a:ext cx="10707624" cy="502920"/>
+          </a:xfrm>
+          <a:prstGeom prst="rect">
+            <a:avLst/>
+          </a:prstGeom>
+          <a:noFill/>
+        </p:spPr>
+        <p:txBody>
+          <a:bodyPr wrap="square" lIns="0" rIns="0" tIns="0" bIns="0" anchor="t">
+            <a:spAutoFit/>
+          </a:bodyPr>
+          <a:lstStyle/>
+          <a:p>
+            <a:pPr algn="l">
+              <a:lnSpc>
+                <a:spcPct val="100000"/>
+              </a:lnSpc>
+              <a:spcAft>
+                <a:spcPts val="100"/>
+              </a:spcAft>
+            </a:pPr>
+            <a:r>
+              <a:rPr sz="1300" b="1" i="0">
+                <a:solidFill>
+                  <a:srgbClr val="1A1A1A"/>
+                </a:solidFill>
+                <a:latin typeface="Calibri"/>
+              </a:rPr>
+              <a:t>Methodology and process for implementation</a:t>
+            </a:r>
+          </a:p>
+          <a:p>
+            <a:pPr algn="l">
+              <a:lnSpc>
+                <a:spcPct val="100000"/>
+              </a:lnSpc>
+              <a:spcAft>
+                <a:spcPts val="0"/>
+              </a:spcAft>
+            </a:pPr>
+            <a:r>
+              <a:rPr sz="1000" b="0" i="1">
+                <a:solidFill>
+                  <a:srgbClr val="505050"/>
+                </a:solidFill>
+                <a:latin typeface="Calibri"/>
+              </a:rPr>
+              <a:t>(Flow Charts / Images / working prototype)</a:t>
+            </a:r>
+          </a:p>
+        </p:txBody>
+      </p:sp>
+      <p:sp>
+        <p:nvSpPr>
+          <p:cNvPr id="17427" name="Rectangle 17426"/>
           <p:cNvSpPr/>
           <p:nvPr/>
         </p:nvSpPr>
         <p:spPr>
           <a:xfrm>
-            <a:off x="502920" y="3621024"/>
-            <a:ext cx="1993392" cy="329184"/>
+            <a:off x="502920" y="3657600"/>
+            <a:ext cx="1993392" cy="1417320"/>
           </a:xfrm>
           <a:prstGeom prst="rect">
             <a:avLst/>
           </a:prstGeom>
           <a:solidFill>
-            <a:srgbClr val="F0F0F0"/>
+            <a:srgbClr val="FFFFFF"/>
           </a:solidFill>
-          <a:ln>
-            <a:noFill/>
+          <a:ln w="9525">
+            <a:solidFill>
+              <a:srgbClr val="BFBFBF"/>
+            </a:solidFill>
           </a:ln>
           <a:effectLst/>
         </p:spPr>
@@ -8308,142 +8388,20 @@
       </p:sp>
       <p:sp>
         <p:nvSpPr>
-          <p:cNvPr id="17427" name="TextBox 17426"/>
-          <p:cNvSpPr txBox="1"/>
+          <p:cNvPr id="17428" name="Rectangle 17427"/>
+          <p:cNvSpPr/>
           <p:nvPr/>
         </p:nvSpPr>
         <p:spPr>
           <a:xfrm>
-            <a:off x="502920" y="3621024"/>
+            <a:off x="502920" y="3657600"/>
             <a:ext cx="1993392" cy="329184"/>
           </a:xfrm>
           <a:prstGeom prst="rect">
             <a:avLst/>
           </a:prstGeom>
-          <a:noFill/>
-        </p:spPr>
-        <p:txBody>
-          <a:bodyPr wrap="square" lIns="0" rIns="0" tIns="0" bIns="0" anchor="ctr">
-            <a:spAutoFit/>
-          </a:bodyPr>
-          <a:lstStyle/>
-          <a:p>
-            <a:pPr algn="ctr">
-              <a:lnSpc>
-                <a:spcPct val="100000"/>
-              </a:lnSpc>
-              <a:spcAft>
-                <a:spcPts val="0"/>
-              </a:spcAft>
-            </a:pPr>
-            <a:r>
-              <a:rPr sz="1150" b="1" i="0">
-                <a:solidFill>
-                  <a:srgbClr val="1F4E79"/>
-                </a:solidFill>
-                <a:latin typeface="Calibri"/>
-              </a:rPr>
-              <a:t>1.  Open data</a:t>
-            </a:r>
-          </a:p>
-        </p:txBody>
-      </p:sp>
-      <p:sp>
-        <p:nvSpPr>
-          <p:cNvPr id="17428" name="TextBox 17427"/>
-          <p:cNvSpPr txBox="1"/>
-          <p:nvPr/>
-        </p:nvSpPr>
-        <p:spPr>
-          <a:xfrm>
-            <a:off x="612648" y="4041648"/>
-            <a:ext cx="1773936" cy="905256"/>
-          </a:xfrm>
-          <a:prstGeom prst="rect">
-            <a:avLst/>
-          </a:prstGeom>
-          <a:noFill/>
-        </p:spPr>
-        <p:txBody>
-          <a:bodyPr wrap="square" lIns="0" rIns="0" tIns="0" bIns="0" anchor="ctr">
-            <a:spAutoFit/>
-          </a:bodyPr>
-          <a:lstStyle/>
-          <a:p>
-            <a:pPr algn="ctr">
-              <a:lnSpc>
-                <a:spcPct val="120000"/>
-              </a:lnSpc>
-              <a:spcAft>
-                <a:spcPts val="200"/>
-              </a:spcAft>
-            </a:pPr>
-            <a:r>
-              <a:rPr sz="1050" b="0" i="0">
-                <a:solidFill>
-                  <a:srgbClr val="505050"/>
-                </a:solidFill>
-                <a:latin typeface="Calibri"/>
-              </a:rPr>
-              <a:t>OSM roads and places</a:t>
-            </a:r>
-          </a:p>
-          <a:p>
-            <a:pPr algn="ctr">
-              <a:lnSpc>
-                <a:spcPct val="120000"/>
-              </a:lnSpc>
-              <a:spcAft>
-                <a:spcPts val="200"/>
-              </a:spcAft>
-            </a:pPr>
-            <a:r>
-              <a:rPr sz="1050" b="0" i="0">
-                <a:solidFill>
-                  <a:srgbClr val="505050"/>
-                </a:solidFill>
-                <a:latin typeface="Calibri"/>
-              </a:rPr>
-              <a:t>NASA rainfall</a:t>
-            </a:r>
-          </a:p>
-          <a:p>
-            <a:pPr algn="ctr">
-              <a:lnSpc>
-                <a:spcPct val="120000"/>
-              </a:lnSpc>
-              <a:spcAft>
-                <a:spcPts val="200"/>
-              </a:spcAft>
-            </a:pPr>
-            <a:r>
-              <a:rPr sz="1050" b="0" i="0">
-                <a:solidFill>
-                  <a:srgbClr val="505050"/>
-                </a:solidFill>
-                <a:latin typeface="Calibri"/>
-              </a:rPr>
-              <a:t>Copernicus elevation</a:t>
-            </a:r>
-          </a:p>
-        </p:txBody>
-      </p:sp>
-      <p:sp>
-        <p:nvSpPr>
-          <p:cNvPr id="17429" name="Right Arrow 17428"/>
-          <p:cNvSpPr/>
-          <p:nvPr/>
-        </p:nvSpPr>
-        <p:spPr>
-          <a:xfrm>
-            <a:off x="2514600" y="4279392"/>
-            <a:ext cx="164592" cy="100584"/>
-          </a:xfrm>
-          <a:prstGeom prst="rightArrow">
-            <a:avLst/>
-          </a:prstGeom>
           <a:solidFill>
-            <a:srgbClr val="BFBFBF"/>
+            <a:srgbClr val="F0F0F0"/>
           </a:solidFill>
           <a:ln>
             <a:noFill/>
@@ -8472,25 +8430,145 @@
       </p:sp>
       <p:sp>
         <p:nvSpPr>
-          <p:cNvPr id="17430" name="Rectangle 17429"/>
-          <p:cNvSpPr/>
+          <p:cNvPr id="17429" name="TextBox 17428"/>
+          <p:cNvSpPr txBox="1"/>
           <p:nvPr/>
         </p:nvSpPr>
         <p:spPr>
           <a:xfrm>
-            <a:off x="2697480" y="3621024"/>
-            <a:ext cx="1993392" cy="1417320"/>
+            <a:off x="502920" y="3657600"/>
+            <a:ext cx="1993392" cy="329184"/>
           </a:xfrm>
           <a:prstGeom prst="rect">
             <a:avLst/>
           </a:prstGeom>
+          <a:noFill/>
+        </p:spPr>
+        <p:txBody>
+          <a:bodyPr wrap="square" lIns="0" rIns="0" tIns="0" bIns="0" anchor="ctr">
+            <a:spAutoFit/>
+          </a:bodyPr>
+          <a:lstStyle/>
+          <a:p>
+            <a:pPr algn="ctr">
+              <a:lnSpc>
+                <a:spcPct val="100000"/>
+              </a:lnSpc>
+              <a:spcAft>
+                <a:spcPts val="0"/>
+              </a:spcAft>
+            </a:pPr>
+            <a:r>
+              <a:rPr sz="1150" b="1" i="0">
+                <a:solidFill>
+                  <a:srgbClr val="1F4E79"/>
+                </a:solidFill>
+                <a:latin typeface="Calibri"/>
+              </a:rPr>
+              <a:t>1.  Open data</a:t>
+            </a:r>
+          </a:p>
+        </p:txBody>
+      </p:sp>
+      <p:sp>
+        <p:nvSpPr>
+          <p:cNvPr id="17430" name="TextBox 17429"/>
+          <p:cNvSpPr txBox="1"/>
+          <p:nvPr/>
+        </p:nvSpPr>
+        <p:spPr>
+          <a:xfrm>
+            <a:off x="612648" y="4078224"/>
+            <a:ext cx="1773936" cy="905256"/>
+          </a:xfrm>
+          <a:prstGeom prst="rect">
+            <a:avLst/>
+          </a:prstGeom>
+          <a:noFill/>
+        </p:spPr>
+        <p:txBody>
+          <a:bodyPr wrap="square" lIns="0" rIns="0" tIns="0" bIns="0" anchor="ctr">
+            <a:spAutoFit/>
+          </a:bodyPr>
+          <a:lstStyle/>
+          <a:p>
+            <a:pPr algn="ctr">
+              <a:lnSpc>
+                <a:spcPct val="120000"/>
+              </a:lnSpc>
+              <a:spcAft>
+                <a:spcPts val="200"/>
+              </a:spcAft>
+            </a:pPr>
+            <a:r>
+              <a:rPr sz="1050" b="0" i="0">
+                <a:solidFill>
+                  <a:srgbClr val="505050"/>
+                </a:solidFill>
+                <a:latin typeface="Calibri"/>
+              </a:rPr>
+              <a:t>OSM roads and places</a:t>
+            </a:r>
+          </a:p>
+          <a:p>
+            <a:pPr algn="ctr">
+              <a:lnSpc>
+                <a:spcPct val="120000"/>
+              </a:lnSpc>
+              <a:spcAft>
+                <a:spcPts val="200"/>
+              </a:spcAft>
+            </a:pPr>
+            <a:r>
+              <a:rPr sz="1050" b="0" i="0">
+                <a:solidFill>
+                  <a:srgbClr val="505050"/>
+                </a:solidFill>
+                <a:latin typeface="Calibri"/>
+              </a:rPr>
+              <a:t>NASA rainfall</a:t>
+            </a:r>
+          </a:p>
+          <a:p>
+            <a:pPr algn="ctr">
+              <a:lnSpc>
+                <a:spcPct val="120000"/>
+              </a:lnSpc>
+              <a:spcAft>
+                <a:spcPts val="200"/>
+              </a:spcAft>
+            </a:pPr>
+            <a:r>
+              <a:rPr sz="1050" b="0" i="0">
+                <a:solidFill>
+                  <a:srgbClr val="505050"/>
+                </a:solidFill>
+                <a:latin typeface="Calibri"/>
+              </a:rPr>
+              <a:t>Copernicus elevation</a:t>
+            </a:r>
+          </a:p>
+        </p:txBody>
+      </p:sp>
+      <p:sp>
+        <p:nvSpPr>
+          <p:cNvPr id="17431" name="Right Arrow 17430"/>
+          <p:cNvSpPr/>
+          <p:nvPr/>
+        </p:nvSpPr>
+        <p:spPr>
+          <a:xfrm>
+            <a:off x="2514600" y="4315968"/>
+            <a:ext cx="164592" cy="100584"/>
+          </a:xfrm>
+          <a:prstGeom prst="rightArrow">
+            <a:avLst/>
+          </a:prstGeom>
           <a:solidFill>
-            <a:srgbClr val="FFFFFF"/>
+            <a:srgbClr val="BFBFBF"/>
           </a:solidFill>
-          <a:ln w="9525">
-            <a:solidFill>
-              <a:srgbClr val="BFBFBF"/>
-            </a:solidFill>
+          <a:ln>
+            <a:noFill/>
           </a:ln>
           <a:effectLst/>
         </p:spPr>
@@ -8516,23 +8594,25 @@
       </p:sp>
       <p:sp>
         <p:nvSpPr>
-          <p:cNvPr id="17431" name="Rectangle 17430"/>
+          <p:cNvPr id="17432" name="Rectangle 17431"/>
           <p:cNvSpPr/>
           <p:nvPr/>
         </p:nvSpPr>
         <p:spPr>
           <a:xfrm>
-            <a:off x="2697480" y="3621024"/>
-            <a:ext cx="1993392" cy="329184"/>
+            <a:off x="2697480" y="3657600"/>
+            <a:ext cx="1993392" cy="1417320"/>
           </a:xfrm>
           <a:prstGeom prst="rect">
             <a:avLst/>
           </a:prstGeom>
           <a:solidFill>
-            <a:srgbClr val="F0F0F0"/>
+            <a:srgbClr val="FFFFFF"/>
           </a:solidFill>
-          <a:ln>
-            <a:noFill/>
+          <a:ln w="9525">
+            <a:solidFill>
+              <a:srgbClr val="BFBFBF"/>
+            </a:solidFill>
           </a:ln>
           <a:effectLst/>
         </p:spPr>
@@ -8558,142 +8638,20 @@
       </p:sp>
       <p:sp>
         <p:nvSpPr>
-          <p:cNvPr id="17432" name="TextBox 17431"/>
-          <p:cNvSpPr txBox="1"/>
+          <p:cNvPr id="17433" name="Rectangle 17432"/>
+          <p:cNvSpPr/>
           <p:nvPr/>
         </p:nvSpPr>
         <p:spPr>
           <a:xfrm>
-            <a:off x="2697480" y="3621024"/>
+            <a:off x="2697480" y="3657600"/>
             <a:ext cx="1993392" cy="329184"/>
           </a:xfrm>
           <a:prstGeom prst="rect">
             <a:avLst/>
           </a:prstGeom>
-          <a:noFill/>
-        </p:spPr>
-        <p:txBody>
-          <a:bodyPr wrap="square" lIns="0" rIns="0" tIns="0" bIns="0" anchor="ctr">
-            <a:spAutoFit/>
-          </a:bodyPr>
-          <a:lstStyle/>
-          <a:p>
-            <a:pPr algn="ctr">
-              <a:lnSpc>
-                <a:spcPct val="100000"/>
-              </a:lnSpc>
-              <a:spcAft>
-                <a:spcPts val="0"/>
-              </a:spcAft>
-            </a:pPr>
-            <a:r>
-              <a:rPr sz="1150" b="1" i="0">
-                <a:solidFill>
-                  <a:srgbClr val="1F4E79"/>
-                </a:solidFill>
-                <a:latin typeface="Calibri"/>
-              </a:rPr>
-              <a:t>2.  Build (offline)</a:t>
-            </a:r>
-          </a:p>
-        </p:txBody>
-      </p:sp>
-      <p:sp>
-        <p:nvSpPr>
-          <p:cNvPr id="17433" name="TextBox 17432"/>
-          <p:cNvSpPr txBox="1"/>
-          <p:nvPr/>
-        </p:nvSpPr>
-        <p:spPr>
-          <a:xfrm>
-            <a:off x="2807208" y="4041648"/>
-            <a:ext cx="1773936" cy="905256"/>
-          </a:xfrm>
-          <a:prstGeom prst="rect">
-            <a:avLst/>
-          </a:prstGeom>
-          <a:noFill/>
-        </p:spPr>
-        <p:txBody>
-          <a:bodyPr wrap="square" lIns="0" rIns="0" tIns="0" bIns="0" anchor="ctr">
-            <a:spAutoFit/>
-          </a:bodyPr>
-          <a:lstStyle/>
-          <a:p>
-            <a:pPr algn="ctr">
-              <a:lnSpc>
-                <a:spcPct val="120000"/>
-              </a:lnSpc>
-              <a:spcAft>
-                <a:spcPts val="200"/>
-              </a:spcAft>
-            </a:pPr>
-            <a:r>
-              <a:rPr sz="1050" b="0" i="0">
-                <a:solidFill>
-                  <a:srgbClr val="505050"/>
-                </a:solidFill>
-                <a:latin typeface="Calibri"/>
-              </a:rPr>
-              <a:t>Turn OSM ways into</a:t>
-            </a:r>
-          </a:p>
-          <a:p>
-            <a:pPr algn="ctr">
-              <a:lnSpc>
-                <a:spcPct val="120000"/>
-              </a:lnSpc>
-              <a:spcAft>
-                <a:spcPts val="200"/>
-              </a:spcAft>
-            </a:pPr>
-            <a:r>
-              <a:rPr sz="1050" b="0" i="0">
-                <a:solidFill>
-                  <a:srgbClr val="505050"/>
-                </a:solidFill>
-                <a:latin typeface="Calibri"/>
-              </a:rPr>
-              <a:t>7,181 scored segments</a:t>
-            </a:r>
-          </a:p>
-          <a:p>
-            <a:pPr algn="ctr">
-              <a:lnSpc>
-                <a:spcPct val="120000"/>
-              </a:lnSpc>
-              <a:spcAft>
-                <a:spcPts val="200"/>
-              </a:spcAft>
-            </a:pPr>
-            <a:r>
-              <a:rPr sz="1050" b="0" i="0">
-                <a:solidFill>
-                  <a:srgbClr val="505050"/>
-                </a:solidFill>
-                <a:latin typeface="Calibri"/>
-              </a:rPr>
-              <a:t>plus 5,594 villages</a:t>
-            </a:r>
-          </a:p>
-        </p:txBody>
-      </p:sp>
-      <p:sp>
-        <p:nvSpPr>
-          <p:cNvPr id="17434" name="Right Arrow 17433"/>
-          <p:cNvSpPr/>
-          <p:nvPr/>
-        </p:nvSpPr>
-        <p:spPr>
-          <a:xfrm>
-            <a:off x="4709160" y="4279392"/>
-            <a:ext cx="164592" cy="100584"/>
-          </a:xfrm>
-          <a:prstGeom prst="rightArrow">
-            <a:avLst/>
-          </a:prstGeom>
           <a:solidFill>
-            <a:srgbClr val="BFBFBF"/>
+            <a:srgbClr val="F0F0F0"/>
           </a:solidFill>
           <a:ln>
             <a:noFill/>
@@ -8722,25 +8680,145 @@
       </p:sp>
       <p:sp>
         <p:nvSpPr>
-          <p:cNvPr id="17435" name="Rectangle 17434"/>
-          <p:cNvSpPr/>
+          <p:cNvPr id="17434" name="TextBox 17433"/>
+          <p:cNvSpPr txBox="1"/>
           <p:nvPr/>
         </p:nvSpPr>
         <p:spPr>
           <a:xfrm>
-            <a:off x="4892040" y="3621024"/>
-            <a:ext cx="1993392" cy="1417320"/>
+            <a:off x="2697480" y="3657600"/>
+            <a:ext cx="1993392" cy="329184"/>
           </a:xfrm>
           <a:prstGeom prst="rect">
             <a:avLst/>
           </a:prstGeom>
+          <a:noFill/>
+        </p:spPr>
+        <p:txBody>
+          <a:bodyPr wrap="square" lIns="0" rIns="0" tIns="0" bIns="0" anchor="ctr">
+            <a:spAutoFit/>
+          </a:bodyPr>
+          <a:lstStyle/>
+          <a:p>
+            <a:pPr algn="ctr">
+              <a:lnSpc>
+                <a:spcPct val="100000"/>
+              </a:lnSpc>
+              <a:spcAft>
+                <a:spcPts val="0"/>
+              </a:spcAft>
+            </a:pPr>
+            <a:r>
+              <a:rPr sz="1150" b="1" i="0">
+                <a:solidFill>
+                  <a:srgbClr val="1F4E79"/>
+                </a:solidFill>
+                <a:latin typeface="Calibri"/>
+              </a:rPr>
+              <a:t>2.  Build (offline)</a:t>
+            </a:r>
+          </a:p>
+        </p:txBody>
+      </p:sp>
+      <p:sp>
+        <p:nvSpPr>
+          <p:cNvPr id="17435" name="TextBox 17434"/>
+          <p:cNvSpPr txBox="1"/>
+          <p:nvPr/>
+        </p:nvSpPr>
+        <p:spPr>
+          <a:xfrm>
+            <a:off x="2807208" y="4078224"/>
+            <a:ext cx="1773936" cy="905256"/>
+          </a:xfrm>
+          <a:prstGeom prst="rect">
+            <a:avLst/>
+          </a:prstGeom>
+          <a:noFill/>
+        </p:spPr>
+        <p:txBody>
+          <a:bodyPr wrap="square" lIns="0" rIns="0" tIns="0" bIns="0" anchor="ctr">
+            <a:spAutoFit/>
+          </a:bodyPr>
+          <a:lstStyle/>
+          <a:p>
+            <a:pPr algn="ctr">
+              <a:lnSpc>
+                <a:spcPct val="120000"/>
+              </a:lnSpc>
+              <a:spcAft>
+                <a:spcPts val="200"/>
+              </a:spcAft>
+            </a:pPr>
+            <a:r>
+              <a:rPr sz="1050" b="0" i="0">
+                <a:solidFill>
+                  <a:srgbClr val="505050"/>
+                </a:solidFill>
+                <a:latin typeface="Calibri"/>
+              </a:rPr>
+              <a:t>Turn OSM ways into</a:t>
+            </a:r>
+          </a:p>
+          <a:p>
+            <a:pPr algn="ctr">
+              <a:lnSpc>
+                <a:spcPct val="120000"/>
+              </a:lnSpc>
+              <a:spcAft>
+                <a:spcPts val="200"/>
+              </a:spcAft>
+            </a:pPr>
+            <a:r>
+              <a:rPr sz="1050" b="0" i="0">
+                <a:solidFill>
+                  <a:srgbClr val="505050"/>
+                </a:solidFill>
+                <a:latin typeface="Calibri"/>
+              </a:rPr>
+              <a:t>7,181 scored segments</a:t>
+            </a:r>
+          </a:p>
+          <a:p>
+            <a:pPr algn="ctr">
+              <a:lnSpc>
+                <a:spcPct val="120000"/>
+              </a:lnSpc>
+              <a:spcAft>
+                <a:spcPts val="200"/>
+              </a:spcAft>
+            </a:pPr>
+            <a:r>
+              <a:rPr sz="1050" b="0" i="0">
+                <a:solidFill>
+                  <a:srgbClr val="505050"/>
+                </a:solidFill>
+                <a:latin typeface="Calibri"/>
+              </a:rPr>
+              <a:t>plus 5,594 villages</a:t>
+            </a:r>
+          </a:p>
+        </p:txBody>
+      </p:sp>
+      <p:sp>
+        <p:nvSpPr>
+          <p:cNvPr id="17436" name="Right Arrow 17435"/>
+          <p:cNvSpPr/>
+          <p:nvPr/>
+        </p:nvSpPr>
+        <p:spPr>
+          <a:xfrm>
+            <a:off x="4709160" y="4315968"/>
+            <a:ext cx="164592" cy="100584"/>
+          </a:xfrm>
+          <a:prstGeom prst="rightArrow">
+            <a:avLst/>
+          </a:prstGeom>
           <a:solidFill>
-            <a:srgbClr val="FFFFFF"/>
+            <a:srgbClr val="BFBFBF"/>
           </a:solidFill>
-          <a:ln w="9525">
-            <a:solidFill>
-              <a:srgbClr val="BFBFBF"/>
-            </a:solidFill>
+          <a:ln>
+            <a:noFill/>
           </a:ln>
           <a:effectLst/>
         </p:spPr>
@@ -8766,23 +8844,25 @@
       </p:sp>
       <p:sp>
         <p:nvSpPr>
-          <p:cNvPr id="17436" name="Rectangle 17435"/>
+          <p:cNvPr id="17437" name="Rectangle 17436"/>
           <p:cNvSpPr/>
           <p:nvPr/>
         </p:nvSpPr>
         <p:spPr>
           <a:xfrm>
-            <a:off x="4892040" y="3621024"/>
-            <a:ext cx="1993392" cy="329184"/>
+            <a:off x="4892040" y="3657600"/>
+            <a:ext cx="1993392" cy="1417320"/>
           </a:xfrm>
           <a:prstGeom prst="rect">
             <a:avLst/>
           </a:prstGeom>
           <a:solidFill>
-            <a:srgbClr val="F0F0F0"/>
+            <a:srgbClr val="FFFFFF"/>
           </a:solidFill>
-          <a:ln>
-            <a:noFill/>
+          <a:ln w="9525">
+            <a:solidFill>
+              <a:srgbClr val="BFBFBF"/>
+            </a:solidFill>
           </a:ln>
           <a:effectLst/>
         </p:spPr>
@@ -8808,142 +8888,20 @@
       </p:sp>
       <p:sp>
         <p:nvSpPr>
-          <p:cNvPr id="17437" name="TextBox 17436"/>
-          <p:cNvSpPr txBox="1"/>
+          <p:cNvPr id="17438" name="Rectangle 17437"/>
+          <p:cNvSpPr/>
           <p:nvPr/>
         </p:nvSpPr>
         <p:spPr>
           <a:xfrm>
-            <a:off x="4892040" y="3621024"/>
+            <a:off x="4892040" y="3657600"/>
             <a:ext cx="1993392" cy="329184"/>
           </a:xfrm>
           <a:prstGeom prst="rect">
             <a:avLst/>
           </a:prstGeom>
-          <a:noFill/>
-        </p:spPr>
-        <p:txBody>
-          <a:bodyPr wrap="square" lIns="0" rIns="0" tIns="0" bIns="0" anchor="ctr">
-            <a:spAutoFit/>
-          </a:bodyPr>
-          <a:lstStyle/>
-          <a:p>
-            <a:pPr algn="ctr">
-              <a:lnSpc>
-                <a:spcPct val="100000"/>
-              </a:lnSpc>
-              <a:spcAft>
-                <a:spcPts val="0"/>
-              </a:spcAft>
-            </a:pPr>
-            <a:r>
-              <a:rPr sz="1150" b="1" i="0">
-                <a:solidFill>
-                  <a:srgbClr val="1F4E79"/>
-                </a:solidFill>
-                <a:latin typeface="Calibri"/>
-              </a:rPr>
-              <a:t>3.  Engine</a:t>
-            </a:r>
-          </a:p>
-        </p:txBody>
-      </p:sp>
-      <p:sp>
-        <p:nvSpPr>
-          <p:cNvPr id="17438" name="TextBox 17437"/>
-          <p:cNvSpPr txBox="1"/>
-          <p:nvPr/>
-        </p:nvSpPr>
-        <p:spPr>
-          <a:xfrm>
-            <a:off x="5001768" y="4041648"/>
-            <a:ext cx="1773936" cy="905256"/>
-          </a:xfrm>
-          <a:prstGeom prst="rect">
-            <a:avLst/>
-          </a:prstGeom>
-          <a:noFill/>
-        </p:spPr>
-        <p:txBody>
-          <a:bodyPr wrap="square" lIns="0" rIns="0" tIns="0" bIns="0" anchor="ctr">
-            <a:spAutoFit/>
-          </a:bodyPr>
-          <a:lstStyle/>
-          <a:p>
-            <a:pPr algn="ctr">
-              <a:lnSpc>
-                <a:spcPct val="120000"/>
-              </a:lnSpc>
-              <a:spcAft>
-                <a:spcPts val="200"/>
-              </a:spcAft>
-            </a:pPr>
-            <a:r>
-              <a:rPr sz="1050" b="0" i="0">
-                <a:solidFill>
-                  <a:srgbClr val="505050"/>
-                </a:solidFill>
-                <a:latin typeface="Calibri"/>
-              </a:rPr>
-              <a:t>Risk model (landslide</a:t>
-            </a:r>
-          </a:p>
-          <a:p>
-            <a:pPr algn="ctr">
-              <a:lnSpc>
-                <a:spcPct val="120000"/>
-              </a:lnSpc>
-              <a:spcAft>
-                <a:spcPts val="200"/>
-              </a:spcAft>
-            </a:pPr>
-            <a:r>
-              <a:rPr sz="1050" b="0" i="0">
-                <a:solidFill>
-                  <a:srgbClr val="505050"/>
-                </a:solidFill>
-                <a:latin typeface="Calibri"/>
-              </a:rPr>
-              <a:t>and flood), cost model,</a:t>
-            </a:r>
-          </a:p>
-          <a:p>
-            <a:pPr algn="ctr">
-              <a:lnSpc>
-                <a:spcPct val="120000"/>
-              </a:lnSpc>
-              <a:spcAft>
-                <a:spcPts val="200"/>
-              </a:spcAft>
-            </a:pPr>
-            <a:r>
-              <a:rPr sz="1050" b="0" i="0">
-                <a:solidFill>
-                  <a:srgbClr val="505050"/>
-                </a:solidFill>
-                <a:latin typeface="Calibri"/>
-              </a:rPr>
-              <a:t>mode-layered graph</a:t>
-            </a:r>
-          </a:p>
-        </p:txBody>
-      </p:sp>
-      <p:sp>
-        <p:nvSpPr>
-          <p:cNvPr id="17439" name="Right Arrow 17438"/>
-          <p:cNvSpPr/>
-          <p:nvPr/>
-        </p:nvSpPr>
-        <p:spPr>
-          <a:xfrm>
-            <a:off x="6903720" y="4279392"/>
-            <a:ext cx="164592" cy="100584"/>
-          </a:xfrm>
-          <a:prstGeom prst="rightArrow">
-            <a:avLst/>
-          </a:prstGeom>
           <a:solidFill>
-            <a:srgbClr val="BFBFBF"/>
+            <a:srgbClr val="F0F0F0"/>
           </a:solidFill>
           <a:ln>
             <a:noFill/>
@@ -8972,25 +8930,145 @@
       </p:sp>
       <p:sp>
         <p:nvSpPr>
-          <p:cNvPr id="17440" name="Rectangle 17439"/>
-          <p:cNvSpPr/>
+          <p:cNvPr id="17439" name="TextBox 17438"/>
+          <p:cNvSpPr txBox="1"/>
           <p:nvPr/>
         </p:nvSpPr>
         <p:spPr>
           <a:xfrm>
-            <a:off x="7086600" y="3621024"/>
-            <a:ext cx="1993392" cy="1417320"/>
+            <a:off x="4892040" y="3657600"/>
+            <a:ext cx="1993392" cy="329184"/>
           </a:xfrm>
           <a:prstGeom prst="rect">
             <a:avLst/>
           </a:prstGeom>
+          <a:noFill/>
+        </p:spPr>
+        <p:txBody>
+          <a:bodyPr wrap="square" lIns="0" rIns="0" tIns="0" bIns="0" anchor="ctr">
+            <a:spAutoFit/>
+          </a:bodyPr>
+          <a:lstStyle/>
+          <a:p>
+            <a:pPr algn="ctr">
+              <a:lnSpc>
+                <a:spcPct val="100000"/>
+              </a:lnSpc>
+              <a:spcAft>
+                <a:spcPts val="0"/>
+              </a:spcAft>
+            </a:pPr>
+            <a:r>
+              <a:rPr sz="1150" b="1" i="0">
+                <a:solidFill>
+                  <a:srgbClr val="1F4E79"/>
+                </a:solidFill>
+                <a:latin typeface="Calibri"/>
+              </a:rPr>
+              <a:t>3.  Engine</a:t>
+            </a:r>
+          </a:p>
+        </p:txBody>
+      </p:sp>
+      <p:sp>
+        <p:nvSpPr>
+          <p:cNvPr id="17440" name="TextBox 17439"/>
+          <p:cNvSpPr txBox="1"/>
+          <p:nvPr/>
+        </p:nvSpPr>
+        <p:spPr>
+          <a:xfrm>
+            <a:off x="5001768" y="4078224"/>
+            <a:ext cx="1773936" cy="905256"/>
+          </a:xfrm>
+          <a:prstGeom prst="rect">
+            <a:avLst/>
+          </a:prstGeom>
+          <a:noFill/>
+        </p:spPr>
+        <p:txBody>
+          <a:bodyPr wrap="square" lIns="0" rIns="0" tIns="0" bIns="0" anchor="ctr">
+            <a:spAutoFit/>
+          </a:bodyPr>
+          <a:lstStyle/>
+          <a:p>
+            <a:pPr algn="ctr">
+              <a:lnSpc>
+                <a:spcPct val="120000"/>
+              </a:lnSpc>
+              <a:spcAft>
+                <a:spcPts val="200"/>
+              </a:spcAft>
+            </a:pPr>
+            <a:r>
+              <a:rPr sz="1050" b="0" i="0">
+                <a:solidFill>
+                  <a:srgbClr val="505050"/>
+                </a:solidFill>
+                <a:latin typeface="Calibri"/>
+              </a:rPr>
+              <a:t>Risk model (landslide</a:t>
+            </a:r>
+          </a:p>
+          <a:p>
+            <a:pPr algn="ctr">
+              <a:lnSpc>
+                <a:spcPct val="120000"/>
+              </a:lnSpc>
+              <a:spcAft>
+                <a:spcPts val="200"/>
+              </a:spcAft>
+            </a:pPr>
+            <a:r>
+              <a:rPr sz="1050" b="0" i="0">
+                <a:solidFill>
+                  <a:srgbClr val="505050"/>
+                </a:solidFill>
+                <a:latin typeface="Calibri"/>
+              </a:rPr>
+              <a:t>and flood), cost model,</a:t>
+            </a:r>
+          </a:p>
+          <a:p>
+            <a:pPr algn="ctr">
+              <a:lnSpc>
+                <a:spcPct val="120000"/>
+              </a:lnSpc>
+              <a:spcAft>
+                <a:spcPts val="200"/>
+              </a:spcAft>
+            </a:pPr>
+            <a:r>
+              <a:rPr sz="1050" b="0" i="0">
+                <a:solidFill>
+                  <a:srgbClr val="505050"/>
+                </a:solidFill>
+                <a:latin typeface="Calibri"/>
+              </a:rPr>
+              <a:t>mode-layered graph</a:t>
+            </a:r>
+          </a:p>
+        </p:txBody>
+      </p:sp>
+      <p:sp>
+        <p:nvSpPr>
+          <p:cNvPr id="17441" name="Right Arrow 17440"/>
+          <p:cNvSpPr/>
+          <p:nvPr/>
+        </p:nvSpPr>
+        <p:spPr>
+          <a:xfrm>
+            <a:off x="6903720" y="4315968"/>
+            <a:ext cx="164592" cy="100584"/>
+          </a:xfrm>
+          <a:prstGeom prst="rightArrow">
+            <a:avLst/>
+          </a:prstGeom>
           <a:solidFill>
-            <a:srgbClr val="FFFFFF"/>
+            <a:srgbClr val="BFBFBF"/>
           </a:solidFill>
-          <a:ln w="9525">
-            <a:solidFill>
-              <a:srgbClr val="BFBFBF"/>
-            </a:solidFill>
+          <a:ln>
+            <a:noFill/>
           </a:ln>
           <a:effectLst/>
         </p:spPr>
@@ -9016,23 +9094,25 @@
       </p:sp>
       <p:sp>
         <p:nvSpPr>
-          <p:cNvPr id="17441" name="Rectangle 17440"/>
+          <p:cNvPr id="17442" name="Rectangle 17441"/>
           <p:cNvSpPr/>
           <p:nvPr/>
         </p:nvSpPr>
         <p:spPr>
           <a:xfrm>
-            <a:off x="7086600" y="3621024"/>
-            <a:ext cx="1993392" cy="329184"/>
+            <a:off x="7086600" y="3657600"/>
+            <a:ext cx="1993392" cy="1417320"/>
           </a:xfrm>
           <a:prstGeom prst="rect">
             <a:avLst/>
           </a:prstGeom>
           <a:solidFill>
-            <a:srgbClr val="F0F0F0"/>
+            <a:srgbClr val="FFFFFF"/>
           </a:solidFill>
-          <a:ln>
-            <a:noFill/>
+          <a:ln w="9525">
+            <a:solidFill>
+              <a:srgbClr val="BFBFBF"/>
+            </a:solidFill>
           </a:ln>
           <a:effectLst/>
         </p:spPr>
@@ -9058,142 +9138,20 @@
       </p:sp>
       <p:sp>
         <p:nvSpPr>
-          <p:cNvPr id="17442" name="TextBox 17441"/>
-          <p:cNvSpPr txBox="1"/>
+          <p:cNvPr id="17443" name="Rectangle 17442"/>
+          <p:cNvSpPr/>
           <p:nvPr/>
         </p:nvSpPr>
         <p:spPr>
           <a:xfrm>
-            <a:off x="7086600" y="3621024"/>
+            <a:off x="7086600" y="3657600"/>
             <a:ext cx="1993392" cy="329184"/>
           </a:xfrm>
           <a:prstGeom prst="rect">
             <a:avLst/>
           </a:prstGeom>
-          <a:noFill/>
-        </p:spPr>
-        <p:txBody>
-          <a:bodyPr wrap="square" lIns="0" rIns="0" tIns="0" bIns="0" anchor="ctr">
-            <a:spAutoFit/>
-          </a:bodyPr>
-          <a:lstStyle/>
-          <a:p>
-            <a:pPr algn="ctr">
-              <a:lnSpc>
-                <a:spcPct val="100000"/>
-              </a:lnSpc>
-              <a:spcAft>
-                <a:spcPts val="0"/>
-              </a:spcAft>
-            </a:pPr>
-            <a:r>
-              <a:rPr sz="1150" b="1" i="0">
-                <a:solidFill>
-                  <a:srgbClr val="1F4E79"/>
-                </a:solidFill>
-                <a:latin typeface="Calibri"/>
-              </a:rPr>
-              <a:t>4.  Answer</a:t>
-            </a:r>
-          </a:p>
-        </p:txBody>
-      </p:sp>
-      <p:sp>
-        <p:nvSpPr>
-          <p:cNvPr id="17443" name="TextBox 17442"/>
-          <p:cNvSpPr txBox="1"/>
-          <p:nvPr/>
-        </p:nvSpPr>
-        <p:spPr>
-          <a:xfrm>
-            <a:off x="7196328" y="4041648"/>
-            <a:ext cx="1773936" cy="905256"/>
-          </a:xfrm>
-          <a:prstGeom prst="rect">
-            <a:avLst/>
-          </a:prstGeom>
-          <a:noFill/>
-        </p:spPr>
-        <p:txBody>
-          <a:bodyPr wrap="square" lIns="0" rIns="0" tIns="0" bIns="0" anchor="ctr">
-            <a:spAutoFit/>
-          </a:bodyPr>
-          <a:lstStyle/>
-          <a:p>
-            <a:pPr algn="ctr">
-              <a:lnSpc>
-                <a:spcPct val="120000"/>
-              </a:lnSpc>
-              <a:spcAft>
-                <a:spcPts val="200"/>
-              </a:spcAft>
-            </a:pPr>
-            <a:r>
-              <a:rPr sz="1050" b="0" i="0">
-                <a:solidFill>
-                  <a:srgbClr val="505050"/>
-                </a:solidFill>
-                <a:latin typeface="Calibri"/>
-              </a:rPr>
-              <a:t>Plan a route, compare</a:t>
-            </a:r>
-          </a:p>
-          <a:p>
-            <a:pPr algn="ctr">
-              <a:lnSpc>
-                <a:spcPct val="120000"/>
-              </a:lnSpc>
-              <a:spcAft>
-                <a:spcPts val="200"/>
-              </a:spcAft>
-            </a:pPr>
-            <a:r>
-              <a:rPr sz="1050" b="0" i="0">
-                <a:solidFill>
-                  <a:srgbClr val="505050"/>
-                </a:solidFill>
-                <a:latin typeface="Calibri"/>
-              </a:rPr>
-              <a:t>options, show risk,</a:t>
-            </a:r>
-          </a:p>
-          <a:p>
-            <a:pPr algn="ctr">
-              <a:lnSpc>
-                <a:spcPct val="120000"/>
-              </a:lnSpc>
-              <a:spcAft>
-                <a:spcPts val="200"/>
-              </a:spcAft>
-            </a:pPr>
-            <a:r>
-              <a:rPr sz="1050" b="0" i="0">
-                <a:solidFill>
-                  <a:srgbClr val="505050"/>
-                </a:solidFill>
-                <a:latin typeface="Calibri"/>
-              </a:rPr>
-              <a:t>show who is cut off</a:t>
-            </a:r>
-          </a:p>
-        </p:txBody>
-      </p:sp>
-      <p:sp>
-        <p:nvSpPr>
-          <p:cNvPr id="17444" name="Right Arrow 17443"/>
-          <p:cNvSpPr/>
-          <p:nvPr/>
-        </p:nvSpPr>
-        <p:spPr>
-          <a:xfrm>
-            <a:off x="9098280" y="4279392"/>
-            <a:ext cx="164592" cy="100584"/>
-          </a:xfrm>
-          <a:prstGeom prst="rightArrow">
-            <a:avLst/>
-          </a:prstGeom>
           <a:solidFill>
-            <a:srgbClr val="BFBFBF"/>
+            <a:srgbClr val="F0F0F0"/>
           </a:solidFill>
           <a:ln>
             <a:noFill/>
@@ -9222,25 +9180,145 @@
       </p:sp>
       <p:sp>
         <p:nvSpPr>
-          <p:cNvPr id="17445" name="Rectangle 17444"/>
-          <p:cNvSpPr/>
+          <p:cNvPr id="17444" name="TextBox 17443"/>
+          <p:cNvSpPr txBox="1"/>
           <p:nvPr/>
         </p:nvSpPr>
         <p:spPr>
           <a:xfrm>
-            <a:off x="9281160" y="3621024"/>
-            <a:ext cx="1993392" cy="1417320"/>
+            <a:off x="7086600" y="3657600"/>
+            <a:ext cx="1993392" cy="329184"/>
           </a:xfrm>
           <a:prstGeom prst="rect">
             <a:avLst/>
           </a:prstGeom>
+          <a:noFill/>
+        </p:spPr>
+        <p:txBody>
+          <a:bodyPr wrap="square" lIns="0" rIns="0" tIns="0" bIns="0" anchor="ctr">
+            <a:spAutoFit/>
+          </a:bodyPr>
+          <a:lstStyle/>
+          <a:p>
+            <a:pPr algn="ctr">
+              <a:lnSpc>
+                <a:spcPct val="100000"/>
+              </a:lnSpc>
+              <a:spcAft>
+                <a:spcPts val="0"/>
+              </a:spcAft>
+            </a:pPr>
+            <a:r>
+              <a:rPr sz="1150" b="1" i="0">
+                <a:solidFill>
+                  <a:srgbClr val="1F4E79"/>
+                </a:solidFill>
+                <a:latin typeface="Calibri"/>
+              </a:rPr>
+              <a:t>4.  Answer</a:t>
+            </a:r>
+          </a:p>
+        </p:txBody>
+      </p:sp>
+      <p:sp>
+        <p:nvSpPr>
+          <p:cNvPr id="17445" name="TextBox 17444"/>
+          <p:cNvSpPr txBox="1"/>
+          <p:nvPr/>
+        </p:nvSpPr>
+        <p:spPr>
+          <a:xfrm>
+            <a:off x="7196328" y="4078224"/>
+            <a:ext cx="1773936" cy="905256"/>
+          </a:xfrm>
+          <a:prstGeom prst="rect">
+            <a:avLst/>
+          </a:prstGeom>
+          <a:noFill/>
+        </p:spPr>
+        <p:txBody>
+          <a:bodyPr wrap="square" lIns="0" rIns="0" tIns="0" bIns="0" anchor="ctr">
+            <a:spAutoFit/>
+          </a:bodyPr>
+          <a:lstStyle/>
+          <a:p>
+            <a:pPr algn="ctr">
+              <a:lnSpc>
+                <a:spcPct val="120000"/>
+              </a:lnSpc>
+              <a:spcAft>
+                <a:spcPts val="200"/>
+              </a:spcAft>
+            </a:pPr>
+            <a:r>
+              <a:rPr sz="1050" b="0" i="0">
+                <a:solidFill>
+                  <a:srgbClr val="505050"/>
+                </a:solidFill>
+                <a:latin typeface="Calibri"/>
+              </a:rPr>
+              <a:t>Plan a route, compare</a:t>
+            </a:r>
+          </a:p>
+          <a:p>
+            <a:pPr algn="ctr">
+              <a:lnSpc>
+                <a:spcPct val="120000"/>
+              </a:lnSpc>
+              <a:spcAft>
+                <a:spcPts val="200"/>
+              </a:spcAft>
+            </a:pPr>
+            <a:r>
+              <a:rPr sz="1050" b="0" i="0">
+                <a:solidFill>
+                  <a:srgbClr val="505050"/>
+                </a:solidFill>
+                <a:latin typeface="Calibri"/>
+              </a:rPr>
+              <a:t>options, show risk,</a:t>
+            </a:r>
+          </a:p>
+          <a:p>
+            <a:pPr algn="ctr">
+              <a:lnSpc>
+                <a:spcPct val="120000"/>
+              </a:lnSpc>
+              <a:spcAft>
+                <a:spcPts val="200"/>
+              </a:spcAft>
+            </a:pPr>
+            <a:r>
+              <a:rPr sz="1050" b="0" i="0">
+                <a:solidFill>
+                  <a:srgbClr val="505050"/>
+                </a:solidFill>
+                <a:latin typeface="Calibri"/>
+              </a:rPr>
+              <a:t>show who is cut off</a:t>
+            </a:r>
+          </a:p>
+        </p:txBody>
+      </p:sp>
+      <p:sp>
+        <p:nvSpPr>
+          <p:cNvPr id="17446" name="Right Arrow 17445"/>
+          <p:cNvSpPr/>
+          <p:nvPr/>
+        </p:nvSpPr>
+        <p:spPr>
+          <a:xfrm>
+            <a:off x="9098280" y="4315968"/>
+            <a:ext cx="164592" cy="100584"/>
+          </a:xfrm>
+          <a:prstGeom prst="rightArrow">
+            <a:avLst/>
+          </a:prstGeom>
           <a:solidFill>
-            <a:srgbClr val="FFFFFF"/>
+            <a:srgbClr val="BFBFBF"/>
           </a:solidFill>
-          <a:ln w="9525">
-            <a:solidFill>
-              <a:srgbClr val="BFBFBF"/>
-            </a:solidFill>
+          <a:ln>
+            <a:noFill/>
           </a:ln>
           <a:effectLst/>
         </p:spPr>
@@ -9266,23 +9344,25 @@
       </p:sp>
       <p:sp>
         <p:nvSpPr>
-          <p:cNvPr id="17446" name="Rectangle 17445"/>
+          <p:cNvPr id="17447" name="Rectangle 17446"/>
           <p:cNvSpPr/>
           <p:nvPr/>
         </p:nvSpPr>
         <p:spPr>
           <a:xfrm>
-            <a:off x="9281160" y="3621024"/>
-            <a:ext cx="1993392" cy="329184"/>
+            <a:off x="9281160" y="3657600"/>
+            <a:ext cx="1993392" cy="1417320"/>
           </a:xfrm>
           <a:prstGeom prst="rect">
             <a:avLst/>
           </a:prstGeom>
           <a:solidFill>
-            <a:srgbClr val="F0F0F0"/>
+            <a:srgbClr val="FFFFFF"/>
           </a:solidFill>
-          <a:ln>
-            <a:noFill/>
+          <a:ln w="9525">
+            <a:solidFill>
+              <a:srgbClr val="BFBFBF"/>
+            </a:solidFill>
           </a:ln>
           <a:effectLst/>
         </p:spPr>
@@ -9308,136 +9388,14 @@
       </p:sp>
       <p:sp>
         <p:nvSpPr>
-          <p:cNvPr id="17447" name="TextBox 17446"/>
-          <p:cNvSpPr txBox="1"/>
-          <p:nvPr/>
-        </p:nvSpPr>
-        <p:spPr>
-          <a:xfrm>
-            <a:off x="9281160" y="3621024"/>
-            <a:ext cx="1993392" cy="329184"/>
-          </a:xfrm>
-          <a:prstGeom prst="rect">
-            <a:avLst/>
-          </a:prstGeom>
-          <a:noFill/>
-        </p:spPr>
-        <p:txBody>
-          <a:bodyPr wrap="square" lIns="0" rIns="0" tIns="0" bIns="0" anchor="ctr">
-            <a:spAutoFit/>
-          </a:bodyPr>
-          <a:lstStyle/>
-          <a:p>
-            <a:pPr algn="ctr">
-              <a:lnSpc>
-                <a:spcPct val="100000"/>
-              </a:lnSpc>
-              <a:spcAft>
-                <a:spcPts val="0"/>
-              </a:spcAft>
-            </a:pPr>
-            <a:r>
-              <a:rPr sz="1150" b="1" i="0">
-                <a:solidFill>
-                  <a:srgbClr val="1F4E79"/>
-                </a:solidFill>
-                <a:latin typeface="Calibri"/>
-              </a:rPr>
-              <a:t>5.  Serve</a:t>
-            </a:r>
-          </a:p>
-        </p:txBody>
-      </p:sp>
-      <p:sp>
-        <p:nvSpPr>
-          <p:cNvPr id="17448" name="TextBox 17447"/>
-          <p:cNvSpPr txBox="1"/>
-          <p:nvPr/>
-        </p:nvSpPr>
-        <p:spPr>
-          <a:xfrm>
-            <a:off x="9390888" y="4041648"/>
-            <a:ext cx="1773936" cy="905256"/>
-          </a:xfrm>
-          <a:prstGeom prst="rect">
-            <a:avLst/>
-          </a:prstGeom>
-          <a:noFill/>
-        </p:spPr>
-        <p:txBody>
-          <a:bodyPr wrap="square" lIns="0" rIns="0" tIns="0" bIns="0" anchor="ctr">
-            <a:spAutoFit/>
-          </a:bodyPr>
-          <a:lstStyle/>
-          <a:p>
-            <a:pPr algn="ctr">
-              <a:lnSpc>
-                <a:spcPct val="120000"/>
-              </a:lnSpc>
-              <a:spcAft>
-                <a:spcPts val="200"/>
-              </a:spcAft>
-            </a:pPr>
-            <a:r>
-              <a:rPr sz="1050" b="0" i="0">
-                <a:solidFill>
-                  <a:srgbClr val="505050"/>
-                </a:solidFill>
-                <a:latin typeface="Calibri"/>
-              </a:rPr>
-              <a:t>One FastAPI process:</a:t>
-            </a:r>
-          </a:p>
-          <a:p>
-            <a:pPr algn="ctr">
-              <a:lnSpc>
-                <a:spcPct val="120000"/>
-              </a:lnSpc>
-              <a:spcAft>
-                <a:spcPts val="200"/>
-              </a:spcAft>
-            </a:pPr>
-            <a:r>
-              <a:rPr sz="1050" b="0" i="0">
-                <a:solidFill>
-                  <a:srgbClr val="505050"/>
-                </a:solidFill>
-                <a:latin typeface="Calibri"/>
-              </a:rPr>
-              <a:t>api and dashboard,</a:t>
-            </a:r>
-          </a:p>
-          <a:p>
-            <a:pPr algn="ctr">
-              <a:lnSpc>
-                <a:spcPct val="120000"/>
-              </a:lnSpc>
-              <a:spcAft>
-                <a:spcPts val="200"/>
-              </a:spcAft>
-            </a:pPr>
-            <a:r>
-              <a:rPr sz="1050" b="0" i="0">
-                <a:solidFill>
-                  <a:srgbClr val="505050"/>
-                </a:solidFill>
-                <a:latin typeface="Calibri"/>
-              </a:rPr>
-              <a:t>no build, no CDN</a:t>
-            </a:r>
-          </a:p>
-        </p:txBody>
-      </p:sp>
-      <p:sp>
-        <p:nvSpPr>
-          <p:cNvPr id="17449" name="Rectangle 17448"/>
+          <p:cNvPr id="17448" name="Rectangle 17447"/>
           <p:cNvSpPr/>
           <p:nvPr/>
         </p:nvSpPr>
         <p:spPr>
           <a:xfrm>
-            <a:off x="502920" y="5221224"/>
-            <a:ext cx="11183112" cy="512064"/>
+            <a:off x="9281160" y="3657600"/>
+            <a:ext cx="1993392" cy="329184"/>
           </a:xfrm>
           <a:prstGeom prst="rect">
             <a:avLst/>
@@ -9472,13 +9430,177 @@
       </p:sp>
       <p:sp>
         <p:nvSpPr>
+          <p:cNvPr id="17449" name="TextBox 17448"/>
+          <p:cNvSpPr txBox="1"/>
+          <p:nvPr/>
+        </p:nvSpPr>
+        <p:spPr>
+          <a:xfrm>
+            <a:off x="9281160" y="3657600"/>
+            <a:ext cx="1993392" cy="329184"/>
+          </a:xfrm>
+          <a:prstGeom prst="rect">
+            <a:avLst/>
+          </a:prstGeom>
+          <a:noFill/>
+        </p:spPr>
+        <p:txBody>
+          <a:bodyPr wrap="square" lIns="0" rIns="0" tIns="0" bIns="0" anchor="ctr">
+            <a:spAutoFit/>
+          </a:bodyPr>
+          <a:lstStyle/>
+          <a:p>
+            <a:pPr algn="ctr">
+              <a:lnSpc>
+                <a:spcPct val="100000"/>
+              </a:lnSpc>
+              <a:spcAft>
+                <a:spcPts val="0"/>
+              </a:spcAft>
+            </a:pPr>
+            <a:r>
+              <a:rPr sz="1150" b="1" i="0">
+                <a:solidFill>
+                  <a:srgbClr val="1F4E79"/>
+                </a:solidFill>
+                <a:latin typeface="Calibri"/>
+              </a:rPr>
+              <a:t>5.  Serve</a:t>
+            </a:r>
+          </a:p>
+        </p:txBody>
+      </p:sp>
+      <p:sp>
+        <p:nvSpPr>
           <p:cNvPr id="17450" name="TextBox 17449"/>
           <p:cNvSpPr txBox="1"/>
           <p:nvPr/>
         </p:nvSpPr>
         <p:spPr>
           <a:xfrm>
-            <a:off x="713232" y="5340096"/>
+            <a:off x="9390888" y="4078224"/>
+            <a:ext cx="1773936" cy="905256"/>
+          </a:xfrm>
+          <a:prstGeom prst="rect">
+            <a:avLst/>
+          </a:prstGeom>
+          <a:noFill/>
+        </p:spPr>
+        <p:txBody>
+          <a:bodyPr wrap="square" lIns="0" rIns="0" tIns="0" bIns="0" anchor="ctr">
+            <a:spAutoFit/>
+          </a:bodyPr>
+          <a:lstStyle/>
+          <a:p>
+            <a:pPr algn="ctr">
+              <a:lnSpc>
+                <a:spcPct val="120000"/>
+              </a:lnSpc>
+              <a:spcAft>
+                <a:spcPts val="200"/>
+              </a:spcAft>
+            </a:pPr>
+            <a:r>
+              <a:rPr sz="1050" b="0" i="0">
+                <a:solidFill>
+                  <a:srgbClr val="505050"/>
+                </a:solidFill>
+                <a:latin typeface="Calibri"/>
+              </a:rPr>
+              <a:t>One FastAPI process:</a:t>
+            </a:r>
+          </a:p>
+          <a:p>
+            <a:pPr algn="ctr">
+              <a:lnSpc>
+                <a:spcPct val="120000"/>
+              </a:lnSpc>
+              <a:spcAft>
+                <a:spcPts val="200"/>
+              </a:spcAft>
+            </a:pPr>
+            <a:r>
+              <a:rPr sz="1050" b="0" i="0">
+                <a:solidFill>
+                  <a:srgbClr val="505050"/>
+                </a:solidFill>
+                <a:latin typeface="Calibri"/>
+              </a:rPr>
+              <a:t>api and dashboard,</a:t>
+            </a:r>
+          </a:p>
+          <a:p>
+            <a:pPr algn="ctr">
+              <a:lnSpc>
+                <a:spcPct val="120000"/>
+              </a:lnSpc>
+              <a:spcAft>
+                <a:spcPts val="200"/>
+              </a:spcAft>
+            </a:pPr>
+            <a:r>
+              <a:rPr sz="1050" b="0" i="0">
+                <a:solidFill>
+                  <a:srgbClr val="505050"/>
+                </a:solidFill>
+                <a:latin typeface="Calibri"/>
+              </a:rPr>
+              <a:t>no build, no CDN</a:t>
+            </a:r>
+          </a:p>
+        </p:txBody>
+      </p:sp>
+      <p:sp>
+        <p:nvSpPr>
+          <p:cNvPr id="17451" name="Rectangle 17450"/>
+          <p:cNvSpPr/>
+          <p:nvPr/>
+        </p:nvSpPr>
+        <p:spPr>
+          <a:xfrm>
+            <a:off x="502920" y="5257800"/>
+            <a:ext cx="11183112" cy="512064"/>
+          </a:xfrm>
+          <a:prstGeom prst="rect">
+            <a:avLst/>
+          </a:prstGeom>
+          <a:solidFill>
+            <a:srgbClr val="F0F0F0"/>
+          </a:solidFill>
+          <a:ln>
+            <a:noFill/>
+          </a:ln>
+          <a:effectLst/>
+        </p:spPr>
+        <p:style>
+          <a:lnRef idx="1">
+            <a:schemeClr val="accent1"/>
+          </a:lnRef>
+          <a:fillRef idx="3">
+            <a:schemeClr val="accent1"/>
+          </a:fillRef>
+          <a:effectRef idx="2">
+            <a:schemeClr val="accent1"/>
+          </a:effectRef>
+          <a:fontRef idx="minor">
+            <a:schemeClr val="lt1"/>
+          </a:fontRef>
+        </p:style>
+        <p:txBody>
+          <a:bodyPr rtlCol="0" anchor="ctr"/>
+          <a:lstStyle/>
+          <a:p/>
+        </p:txBody>
+      </p:sp>
+      <p:sp>
+        <p:nvSpPr>
+          <p:cNvPr id="17452" name="TextBox 17451"/>
+          <p:cNvSpPr txBox="1"/>
+          <p:nvPr/>
+        </p:nvSpPr>
+        <p:spPr>
+          <a:xfrm>
+            <a:off x="713232" y="5376672"/>
             <a:ext cx="10762488" cy="292608"/>
           </a:xfrm>
           <a:prstGeom prst="rect">

</xml_diff>